<commit_message>
alterações discretas, esperando novos orçamentos
</commit_message>
<xml_diff>
--- a/templates/template_ANC-T.pptx
+++ b/templates/template_ANC-T.pptx
@@ -284,7 +284,7 @@
       </p15:sldGuideLst>
     </p:ext>
     <p:ext uri="GoogleSlidesCustomDataVersion2">
-      <go:slidesCustomData xmlns:go="http://customooxmlschemas.google.com/" xmlns:ahyp="http://schemas.microsoft.com/office/drawing/2018/hyperlinkcolor" xmlns:p15="http://schemas.microsoft.com/office/powerpoint/2012/main" xmlns:p14="http://schemas.microsoft.com/office/powerpoint/2010/main" xmlns:com="http://schemas.openxmlformats.org/drawingml/2006/compatibility" xmlns:pvml="urn:schemas-microsoft-com:office:powerpoint" xmlns:v="urn:schemas-microsoft-com:vml" xmlns:o="urn:schemas-microsoft-com:office:office" xmlns:dgm="http://schemas.openxmlformats.org/drawingml/2006/diagram" xmlns:c="http://schemas.openxmlformats.org/drawingml/2006/chart" xmlns:mv="urn:schemas-microsoft-com:mac:vml" xmlns:mc="http://schemas.openxmlformats.org/markup-compatibility/2006" xmlns="" r:id="rId24" roundtripDataSignature="AMtx7mgm3cI3PwSj3oYKiuDx8kCP+3Um9Q=="/>
+      <go:slidesCustomData xmlns="" xmlns:mc="http://schemas.openxmlformats.org/markup-compatibility/2006" xmlns:mv="urn:schemas-microsoft-com:mac:vml" xmlns:c="http://schemas.openxmlformats.org/drawingml/2006/chart" xmlns:dgm="http://schemas.openxmlformats.org/drawingml/2006/diagram" xmlns:o="urn:schemas-microsoft-com:office:office" xmlns:v="urn:schemas-microsoft-com:vml" xmlns:pvml="urn:schemas-microsoft-com:office:powerpoint" xmlns:com="http://schemas.openxmlformats.org/drawingml/2006/compatibility" xmlns:p14="http://schemas.microsoft.com/office/powerpoint/2010/main" xmlns:p15="http://schemas.microsoft.com/office/powerpoint/2012/main" xmlns:ahyp="http://schemas.microsoft.com/office/drawing/2018/hyperlinkcolor" xmlns:go="http://customooxmlschemas.google.com/" r:id="rId24" roundtripDataSignature="AMtx7mgm3cI3PwSj3oYKiuDx8kCP+3Um9Q=="/>
     </p:ext>
   </p:extLst>
 </p:presentation>
@@ -14017,7 +14017,7 @@
         <p:spPr>
           <a:xfrm>
             <a:off x="292950" y="964950"/>
-            <a:ext cx="8958000" cy="4078009"/>
+            <a:ext cx="8958000" cy="3770233"/>
           </a:xfrm>
           <a:prstGeom prst="rect">
             <a:avLst/>
@@ -14162,12 +14162,15 @@
             </a:r>
             <a:r>
               <a:rPr lang="pt-BR" sz="1100" dirty="0" err="1">
+                <a:solidFill>
+                  <a:schemeClr val="tx1"/>
+                </a:solidFill>
                 <a:latin typeface="Inter"/>
                 <a:ea typeface="Inter"/>
                 <a:cs typeface="Inter"/>
                 <a:sym typeface="Inter"/>
               </a:rPr>
-              <a:t>diametro</a:t>
+              <a:t>diametro_corpo</a:t>
             </a:r>
             <a:r>
               <a:rPr lang="pt-BR" sz="1100" dirty="0">
@@ -14212,7 +14215,7 @@
                 <a:cs typeface="Inter"/>
                 <a:sym typeface="Inter"/>
               </a:rPr>
-              <a:t>}}// R$ {{</a:t>
+              <a:t>}} (Unitário) // R$ {{</a:t>
             </a:r>
             <a:r>
               <a:rPr lang="pt-BR" sz="1100" dirty="0" err="1">
@@ -14230,7 +14233,7 @@
                 <a:cs typeface="Inter"/>
                 <a:sym typeface="Inter"/>
               </a:rPr>
-              <a:t>}}</a:t>
+              <a:t>}} (Lote)</a:t>
             </a:r>
           </a:p>
           <a:p>
@@ -14785,10 +14788,25 @@
                 <a:cs typeface="Inter"/>
                 <a:sym typeface="Inter"/>
               </a:rPr>
-              <a:t>Envio:</a:t>
-            </a:r>
-            <a:r>
-              <a:rPr lang="pt-BR" sz="1100" b="1" i="0" u="none" strike="noStrike" cap="none" dirty="0">
+              <a:t>Envio</a:t>
+            </a:r>
+            <a:r>
+              <a:rPr lang="pt-BR" sz="1100" b="1" i="0" u="none" strike="noStrike" cap="none">
+                <a:solidFill>
+                  <a:srgbClr val="FF008C"/>
+                </a:solidFill>
+                <a:highlight>
+                  <a:srgbClr val="FFFFFF"/>
+                </a:highlight>
+                <a:latin typeface="Inter"/>
+                <a:ea typeface="Inter"/>
+                <a:cs typeface="Inter"/>
+                <a:sym typeface="Inter"/>
+              </a:rPr>
+              <a:t>:</a:t>
+            </a:r>
+            <a:r>
+              <a:rPr lang="pt-BR" sz="1100" b="1" i="0" u="none" strike="noStrike" cap="none">
                 <a:solidFill>
                   <a:srgbClr val="FFFFFF"/>
                 </a:solidFill>
@@ -14803,7 +14821,7 @@
               <a:t>: </a:t>
             </a:r>
             <a:r>
-              <a:rPr lang="pt-BR" sz="1100" b="1" i="0" u="none" strike="noStrike" cap="none" dirty="0">
+              <a:rPr lang="pt-BR" sz="1100" b="1" i="0" u="none" strike="noStrike" cap="none">
                 <a:solidFill>
                   <a:srgbClr val="FF008C"/>
                 </a:solidFill>
@@ -14815,7 +14833,7 @@
               <a:t> </a:t>
             </a:r>
             <a:r>
-              <a:rPr lang="pt-BR" sz="1100" b="0" i="0" u="none" strike="noStrike" cap="none" dirty="0">
+              <a:rPr lang="pt-BR" sz="1100" b="0" i="0" u="none" strike="noStrike" cap="none">
                 <a:solidFill>
                   <a:srgbClr val="000000"/>
                 </a:solidFill>
@@ -14826,28 +14844,17 @@
               </a:rPr>
               <a:t> </a:t>
             </a:r>
-            <a:endParaRPr sz="1100" b="0" i="0" u="none" strike="noStrike" cap="none" dirty="0">
-              <a:solidFill>
-                <a:srgbClr val="000000"/>
-              </a:solidFill>
-              <a:latin typeface="Inter"/>
-              <a:ea typeface="Inter"/>
-              <a:cs typeface="Inter"/>
-              <a:sym typeface="Inter"/>
-            </a:endParaRPr>
-          </a:p>
-          <a:p>
-            <a:pPr lvl="0">
-              <a:spcBef>
-                <a:spcPts val="1200"/>
-              </a:spcBef>
-              <a:spcAft>
-                <a:spcPts val="1200"/>
-              </a:spcAft>
-              <a:buSzPts val="1100"/>
-            </a:pPr>
             <a:r>
               <a:rPr lang="pt-BR" sz="1100" dirty="0">
+                <a:latin typeface="Inter"/>
+                <a:ea typeface="Inter"/>
+                <a:cs typeface="Inter"/>
+                <a:sym typeface="Inter"/>
+              </a:rPr>
+              <a:t>	</a:t>
+            </a:r>
+            <a:r>
+              <a:rPr lang="pt-BR" sz="1100">
                 <a:latin typeface="Inter"/>
                 <a:ea typeface="Inter"/>
                 <a:cs typeface="Inter"/>

</xml_diff>